<commit_message>
Remove year from title slide
Co-Authored-By: Claude Sonnet 4.6 <noreply@anthropic.com>
Claude-Session: https://claude.ai/code/session_014t6tUb6sstY7NHUN5o5oVx
</commit_message>
<xml_diff>
--- a/coaxial_cable.pptx
+++ b/coaxial_cable.pptx
@@ -1685,42 +1685,6 @@
           </a:p>
         </p:txBody>
       </p:sp>
-      <p:sp>
-        <p:nvSpPr>
-          <p:cNvPr id="11" name="Text 9"/>
-          <p:cNvSpPr txBox="1"/>
-          <p:nvPr/>
-        </p:nvSpPr>
-        <p:spPr>
-          <a:xfrm>
-            <a:off x="457200" y="4480560"/>
-            <a:ext cx="8229600" cy="320040"/>
-          </a:xfrm>
-          <a:prstGeom prst="rect">
-            <a:avLst/>
-          </a:prstGeom>
-          <a:noFill/>
-          <a:ln/>
-        </p:spPr>
-        <p:txBody>
-          <a:bodyPr wrap="square" rtlCol="0" anchor="ctr"/>
-          <a:lstStyle/>
-          <a:p>
-            <a:pPr algn="ctr" indent="0" marL="0">
-              <a:buNone/>
-            </a:pPr>
-            <a:r>
-              <a:rPr lang="en-US" sz="1300" dirty="0">
-                <a:solidFill>
-                  <a:srgbClr val="B0BEC5"/>
-                </a:solidFill>
-              </a:rPr>
-              <a:t>2024 г.</a:t>
-            </a:r>
-            <a:endParaRPr lang="en-US" sz="1300" dirty="0"/>
-          </a:p>
-        </p:txBody>
-      </p:sp>
     </p:spTree>
   </p:cSld>
   <p:clrMapOvr>

</xml_diff>